<commit_message>
chore(docs): remove AI-session leftovers and rebuild stale chatbot artifacts
Delete one-shot run_manual_* scripts, chat transcript dump, BAO_CAO_AI session report, placeholder logo, superseded pipeline.workflow.json draft, duplicate legacy tuning history and redundant .gitkeep files; drop slides/img copies that make_charts.py re-copies on every build. Rebuild report docx and flow figures, update slide deck (outline, script, build_pptx, chatbot_flow chart) from SCI wording to the Action-Decision two-call architecture (decision + grounded compose with formatter fallback), re-render chatbot-workflow.html and luuDo/01 runtime diagram, and refresh LEGACY_STALE markers plus GIAI_THICH_PROJECT.md to match.

Co-authored-by: Cursor <cursoragent@cursor.com>
</commit_message>
<xml_diff>
--- a/docs/slides/thuyet_trinh_nien_luan.pptx
+++ b/docs/slides/thuyet_trinh_nien_luan.pptx
@@ -595,7 +595,7 @@
           <a:lstStyle/>
           <a:p>
             <a:r>
-              <a:t>Chatbot dùng structured context injection: không vector database, không embedding, không provider tool-calling. Server khớp keyword để chọn nguồn dữ liệu, dựng context từ signal, metadata và report đã publish, rồi gọi LLM đúng một lần. Sources, warnings, release status và canonical state do server giữ riêng; grounding đối chiếu mã, trường và giá trị sau khi LLM trả lời. Hệ thống cho phép nhận định xu hướng phù hợp dữ liệu nhưng chặn khuyến nghị mua bán trực tiếp. Dock và trang chat dùng chung sessionStorage; provider lỗi trả mã lỗi rõ, không fallback local.</a:t>
+              <a:t>Chatbot chạy kiến trúc Action-Decision: LLM call thứ nhất chỉ chọn đúng một trong năm action là GENERAL_CHAT, STOCK_SIGNAL, STOCK_RANKING, PROJECT_INFO, OUT_OF_SCOPE kèm arguments theo schema cố định. Backend validate lại schema rồi kiểm symbol scope tập trung, sau đó một dispatcher cố định gọi handler tương ứng; mọi prediction, Điểm UP, xếp hạng và metric đều do backend tính từ artifact đã publish. LLM call thứ hai chỉ diễn đạt lại câu trả lời từ JSON số liệu backend đưa, không được thêm số mới, và nếu call này lỗi hoặc quá deadline thì hệ thống giữ nguyên bản formatter deterministic. Không có vector database, embedding, tool loop hay router keyword; trang /chat và dock nổi dùng chung một API. Decision sai protocol trả 502, nguồn dữ liệu chưa sẵn sàng trả 503 và quá deadline trả 504.</a:t>
             </a:r>
           </a:p>
         </p:txBody>
@@ -665,7 +665,7 @@
           <a:lstStyle/>
           <a:p>
             <a:r>
-              <a:t>Đây là ảnh chụp thật từ phiên làm việc với Flask đang chạy, không phải ảnh minh họa. Câu đầu tiên cho thấy chatbot trả đúng các số trên TEST, trùng khớp với bảng ở slide kết quả. Câu thứ hai trả về Điểm UP của FPT kèm ngưỡng quyết định, và nói rõ đây là dữ liệu offline chứ không phải giá hiện tại. Câu thứ ba hỏi về P/E và tin tức thì chatbot từ chối và gợi lại đúng phạm vi hỗ trợ, đó là cơ chế chặn bịa số liệu. Ba cảnh báo bên dưới luôn đi kèm: policy legacy, chưa vượt baseline và symbol scope chưa verified.</a:t>
+              <a:t>Đây là ảnh chụp thật từ phiên làm việc với Flask đang chạy, không phải ảnh minh họa. Câu đầu hỏi về model và kết quả TEST nên decision chọn PROJECT_INFO, số trả về trùng khớp bảng ở slide kết quả. Câu thứ hai hỏi FPT nên decision chọn STOCK_SIGNAL, backend kiểm scope rồi chạy inference và trả Điểm UP kèm ngưỡng quyết định. Câu thứ ba hỏi P/E và tin tức nên decision chọn OUT_OF_SCOPE, chatbot từ chối và nêu lại đúng những việc nó làm được. Cả ba câu không có con số nào do LLM tự viết ra, và disclaimer dữ liệu offline do backend gắn vào cuối trang.</a:t>
             </a:r>
           </a:p>
         </p:txBody>
@@ -5487,7 +5487,7 @@
                 </a:solidFill>
                 <a:latin typeface="Arial"/>
               </a:rPr>
-              <a:t>Chatbot dùng structured context injection (SCI)</a:t>
+              <a:t>Chatbot Action-Decision: LLM chọn action, backend giữ số liệu</a:t>
             </a:r>
           </a:p>
           <a:p>
@@ -5537,7 +5537,7 @@
                 </a:solidFill>
                 <a:latin typeface="Arial"/>
               </a:rPr>
-              <a:t>– Server chọn context trước, LLM diễn giải sau</a:t>
+              <a:t>– LLM decision chọn đúng một trong năm action</a:t>
             </a:r>
           </a:p>
           <a:p>
@@ -5553,7 +5553,7 @@
                 </a:solidFill>
                 <a:latin typeface="Arial"/>
               </a:rPr>
-              <a:t>– Đúng một LLM call, không tools/tool_choice</a:t>
+              <a:t>– Backend validate schema và kiểm symbol scope</a:t>
             </a:r>
           </a:p>
           <a:p>
@@ -5569,7 +5569,7 @@
                 </a:solidFill>
                 <a:latin typeface="Arial"/>
               </a:rPr>
-              <a:t>– Chỉ đọc artifact đã publish, không train lại</a:t>
+              <a:t>– Dispatcher cố định gọi handler, không tool loop</a:t>
             </a:r>
           </a:p>
           <a:p>
@@ -5585,7 +5585,7 @@
                 </a:solidFill>
                 <a:latin typeface="Arial"/>
               </a:rPr>
-              <a:t>– Mã ngoài symbol scope bị từ chối</a:t>
+              <a:t>– Mọi số liệu do backend tính, LLM không tạo</a:t>
             </a:r>
           </a:p>
           <a:p>
@@ -5601,7 +5601,7 @@
                 </a:solidFill>
                 <a:latin typeface="Arial"/>
               </a:rPr>
-              <a:t>– Grounding chặn số sai và tư vấn mua bán</a:t>
+              <a:t>– Compose diễn đạt lại, lỗi thì giữ formatter</a:t>
             </a:r>
           </a:p>
           <a:p>
@@ -5617,7 +5617,7 @@
                 </a:solidFill>
                 <a:latin typeface="Arial"/>
               </a:rPr>
-              <a:t>– Không có API key thì trả 503, không bịa</a:t>
+              <a:t>– Không RAG, không vector DB, không embedding</a:t>
             </a:r>
           </a:p>
         </p:txBody>
@@ -5704,7 +5704,7 @@
                           </a:solidFill>
                           <a:latin typeface="Arial"/>
                         </a:rPr>
-                        <a:t>LLM call mỗi lượt</a:t>
+                        <a:t>LLM call: decision + compose</a:t>
                       </a:r>
                     </a:p>
                   </a:txBody>
@@ -5727,7 +5727,7 @@
                           </a:solidFill>
                           <a:latin typeface="Arial"/>
                         </a:rPr>
-                        <a:t>1</a:t>
+                        <a:t>2</a:t>
                       </a:r>
                     </a:p>
                   </a:txBody>
@@ -5751,7 +5751,7 @@
                           </a:solidFill>
                           <a:latin typeface="Arial"/>
                         </a:rPr>
-                        <a:t>Context JSON</a:t>
+                        <a:t>Action trong whitelist</a:t>
                       </a:r>
                     </a:p>
                   </a:txBody>
@@ -5774,7 +5774,7 @@
                           </a:solidFill>
                           <a:latin typeface="Arial"/>
                         </a:rPr>
-                        <a:t>Tối đa 16.000 ký tự</a:t>
+                        <a:t>5</a:t>
                       </a:r>
                     </a:p>
                   </a:txBody>
@@ -5821,7 +5821,7 @@
                           </a:solidFill>
                           <a:latin typeface="Arial"/>
                         </a:rPr>
-                        <a:t>3 cặp hỏi đáp</a:t>
+                        <a:t>3 cặp</a:t>
                       </a:r>
                     </a:p>
                   </a:txBody>
@@ -5845,7 +5845,7 @@
                           </a:solidFill>
                           <a:latin typeface="Arial"/>
                         </a:rPr>
-                        <a:t>Memory</a:t>
+                        <a:t>Fallback khi compose lỗi</a:t>
                       </a:r>
                     </a:p>
                   </a:txBody>
@@ -5868,7 +5868,7 @@
                           </a:solidFill>
                           <a:latin typeface="Arial"/>
                         </a:rPr>
-                        <a:t>sessionStorage dùng chung</a:t>
+                        <a:t>Formatter</a:t>
                       </a:r>
                     </a:p>
                   </a:txBody>
@@ -5936,7 +5936,7 @@
                 </a:solidFill>
                 <a:latin typeface="Arial"/>
               </a:rPr>
-              <a:t>Nguồn: services/chatbot_tools.py, services/chatbot_service.py, tests/test_chatbot*.py</a:t>
+              <a:t>Nguồn: docs/CHATBOT_ARCHITECTURE.md, services/chatbot_service.py, services/chatbot_tools.py</a:t>
             </a:r>
           </a:p>
         </p:txBody>
@@ -6106,7 +6106,7 @@
                 </a:solidFill>
                 <a:latin typeface="Arial"/>
               </a:rPr>
-              <a:t>– Câu 1: model và kết quả TEST, đọc từ metadata</a:t>
+              <a:t>– Câu 1: PROJECT_INFO, model và kết quả TEST</a:t>
             </a:r>
           </a:p>
           <a:p>
@@ -6122,7 +6122,7 @@
                 </a:solidFill>
                 <a:latin typeface="Arial"/>
               </a:rPr>
-              <a:t>– Câu 2: tín hiệu FPT, kèm Điểm UP và ngưỡng</a:t>
+              <a:t>– Câu 2: STOCK_SIGNAL FPT, Điểm UP và ngưỡng</a:t>
             </a:r>
           </a:p>
           <a:p>
@@ -6138,7 +6138,7 @@
                 </a:solidFill>
                 <a:latin typeface="Arial"/>
               </a:rPr>
-              <a:t>– Câu 3: hỏi P/E và tin tức thì bị từ chối</a:t>
+              <a:t>– Câu 3: OUT_OF_SCOPE, hỏi P/E và tin tức</a:t>
             </a:r>
           </a:p>
           <a:p>
@@ -6154,7 +6154,7 @@
                 </a:solidFill>
                 <a:latin typeface="Arial"/>
               </a:rPr>
-              <a:t>– Mọi câu trả lời đều kèm cảnh báo baseline</a:t>
+              <a:t>– Số liệu do backend tính, LLM chỉ diễn đạt</a:t>
             </a:r>
           </a:p>
           <a:p>
@@ -15941,8 +15941,8 @@
         </p:blipFill>
         <p:spPr>
           <a:xfrm>
-            <a:off x="873544" y="1463040"/>
-            <a:ext cx="6482512" cy="4480560"/>
+            <a:off x="1138233" y="1463040"/>
+            <a:ext cx="5953134" cy="4480560"/>
           </a:xfrm>
           <a:prstGeom prst="rect">
             <a:avLst/>

</xml_diff>